<commit_message>
budget metric: report population mean (1.5%) and among-buyers mean (8.5%) side by side + method note on Q9 collection; update copil slide
</commit_message>
<xml_diff>
--- a/outputs/presentations/copil_vente_directe.pptx
+++ b/outputs/presentations/copil_vente_directe.pptx
@@ -4417,7 +4417,7 @@
                 </a:solidFill>
                 <a:latin typeface="Calibri"/>
               </a:rPr>
-              <a:t>seulement du budget</a:t>
+              <a:t>du budget national</a:t>
             </a:r>
           </a:p>
           <a:p>
@@ -4433,7 +4433,7 @@
                 </a:solidFill>
                 <a:latin typeface="Calibri"/>
               </a:rPr>
-              <a:t>alimentaire</a:t>
+              <a:t>(mais 8,5 % chez ses réguliers)</a:t>
             </a:r>
           </a:p>
         </p:txBody>
@@ -4628,13 +4628,13 @@
               </a:lnSpc>
             </a:pPr>
             <a:r>
-              <a:rPr sz="1500" b="1">
+              <a:rPr sz="1400" b="1">
                 <a:solidFill>
                   <a:srgbClr val="2E5E3A"/>
                 </a:solidFill>
                 <a:latin typeface="Calibri"/>
               </a:rPr>
-              <a:t>→ Un canal de complémentarité ciblée, non de substitution.</a:t>
+              <a:t>→ Marginal à l'échelle du pays, non négligeable pour ses adeptes : complément, non substitut.</a:t>
             </a:r>
           </a:p>
         </p:txBody>

</xml_diff>